<commit_message>
docs: replace deck emoji with brand gold vector icons
Hand-drawn line-icon set (house/box/pot/money/id/phone/bolt) via PowerPoint
auto-shapes in the gold brand tone; verified by rendering. No more emoji.

Co-Authored-By: Claude Fable 5 <noreply@anthropic.com>
</commit_message>
<xml_diff>
--- a/docs/IEUM_Pitch_Deck.pptx
+++ b/docs/IEUM_Pitch_Deck.pptx
@@ -4801,48 +4801,139 @@
       </p:sp>
       <p:sp>
         <p:nvSpPr>
-          <p:cNvPr id="11" name="TextBox 10"/>
-          <p:cNvSpPr txBox="1"/>
-          <p:nvPr/>
-        </p:nvSpPr>
-        <p:spPr>
-          <a:xfrm>
-            <a:off x="1161288" y="3246120"/>
-            <a:ext cx="822960" cy="749808"/>
-          </a:xfrm>
-          <a:prstGeom prst="rect">
-            <a:avLst/>
-          </a:prstGeom>
-          <a:noFill/>
-        </p:spPr>
-        <p:txBody>
-          <a:bodyPr wrap="square" anchor="ctr" lIns="0" rIns="0" tIns="0" bIns="0">
-            <a:spAutoFit/>
-          </a:bodyPr>
-          <a:lstStyle/>
-          <a:p>
-            <a:pPr algn="l">
-              <a:lnSpc>
-                <a:spcPct val="100000"/>
-              </a:lnSpc>
-            </a:pPr>
-            <a:r>
-              <a:rPr sz="2600" b="0" i="0">
-                <a:solidFill>
-                  <a:srgbClr val="F5F5F3"/>
-                </a:solidFill>
-                <a:latin typeface="Segoe UI"/>
-                <a:ea typeface="Malgun Gothic"/>
-                <a:cs typeface="Segoe UI"/>
-              </a:rPr>
-              <a:t>🏠</a:t>
-            </a:r>
-          </a:p>
-        </p:txBody>
-      </p:sp>
-      <p:sp>
-        <p:nvSpPr>
-          <p:cNvPr id="12" name="TextBox 11"/>
+          <p:cNvPr id="11" name="Isosceles Triangle 10"/>
+          <p:cNvSpPr/>
+          <p:nvPr/>
+        </p:nvSpPr>
+        <p:spPr>
+          <a:xfrm>
+            <a:off x="1316736" y="3438144"/>
+            <a:ext cx="365760" cy="173736"/>
+          </a:xfrm>
+          <a:prstGeom prst="triangle">
+            <a:avLst/>
+          </a:prstGeom>
+          <a:noFill/>
+          <a:ln w="24130">
+            <a:solidFill>
+              <a:srgbClr val="E7B75F"/>
+            </a:solidFill>
+          </a:ln>
+          <a:effectLst/>
+        </p:spPr>
+        <p:style>
+          <a:lnRef idx="1">
+            <a:schemeClr val="accent1"/>
+          </a:lnRef>
+          <a:fillRef idx="3">
+            <a:schemeClr val="accent1"/>
+          </a:fillRef>
+          <a:effectRef idx="2">
+            <a:schemeClr val="accent1"/>
+          </a:effectRef>
+          <a:fontRef idx="minor">
+            <a:schemeClr val="lt1"/>
+          </a:fontRef>
+        </p:style>
+        <p:txBody>
+          <a:bodyPr rtlCol="0" anchor="ctr"/>
+          <a:lstStyle/>
+          <a:p>
+            <a:pPr algn="ctr"/>
+          </a:p>
+        </p:txBody>
+      </p:sp>
+      <p:sp>
+        <p:nvSpPr>
+          <p:cNvPr id="12" name="Rectangle 11"/>
+          <p:cNvSpPr/>
+          <p:nvPr/>
+        </p:nvSpPr>
+        <p:spPr>
+          <a:xfrm>
+            <a:off x="1367942" y="3602736"/>
+            <a:ext cx="263347" cy="186537"/>
+          </a:xfrm>
+          <a:prstGeom prst="rect">
+            <a:avLst/>
+          </a:prstGeom>
+          <a:noFill/>
+          <a:ln w="24130">
+            <a:solidFill>
+              <a:srgbClr val="E7B75F"/>
+            </a:solidFill>
+          </a:ln>
+          <a:effectLst/>
+        </p:spPr>
+        <p:style>
+          <a:lnRef idx="1">
+            <a:schemeClr val="accent1"/>
+          </a:lnRef>
+          <a:fillRef idx="3">
+            <a:schemeClr val="accent1"/>
+          </a:fillRef>
+          <a:effectRef idx="2">
+            <a:schemeClr val="accent1"/>
+          </a:effectRef>
+          <a:fontRef idx="minor">
+            <a:schemeClr val="lt1"/>
+          </a:fontRef>
+        </p:style>
+        <p:txBody>
+          <a:bodyPr rtlCol="0" anchor="ctr"/>
+          <a:lstStyle/>
+          <a:p>
+            <a:pPr algn="ctr"/>
+          </a:p>
+        </p:txBody>
+      </p:sp>
+      <p:sp>
+        <p:nvSpPr>
+          <p:cNvPr id="13" name="Rectangle 12"/>
+          <p:cNvSpPr/>
+          <p:nvPr/>
+        </p:nvSpPr>
+        <p:spPr>
+          <a:xfrm>
+            <a:off x="1463040" y="3686860"/>
+            <a:ext cx="73152" cy="102412"/>
+          </a:xfrm>
+          <a:prstGeom prst="rect">
+            <a:avLst/>
+          </a:prstGeom>
+          <a:noFill/>
+          <a:ln w="24130">
+            <a:solidFill>
+              <a:srgbClr val="E7B75F"/>
+            </a:solidFill>
+          </a:ln>
+          <a:effectLst/>
+        </p:spPr>
+        <p:style>
+          <a:lnRef idx="1">
+            <a:schemeClr val="accent1"/>
+          </a:lnRef>
+          <a:fillRef idx="3">
+            <a:schemeClr val="accent1"/>
+          </a:fillRef>
+          <a:effectRef idx="2">
+            <a:schemeClr val="accent1"/>
+          </a:effectRef>
+          <a:fontRef idx="minor">
+            <a:schemeClr val="lt1"/>
+          </a:fontRef>
+        </p:style>
+        <p:txBody>
+          <a:bodyPr rtlCol="0" anchor="ctr"/>
+          <a:lstStyle/>
+          <a:p>
+            <a:pPr algn="ctr"/>
+          </a:p>
+        </p:txBody>
+      </p:sp>
+      <p:sp>
+        <p:nvSpPr>
+          <p:cNvPr id="14" name="TextBox 13"/>
           <p:cNvSpPr txBox="1"/>
           <p:nvPr/>
         </p:nvSpPr>
@@ -4883,7 +4974,7 @@
       </p:sp>
       <p:sp>
         <p:nvSpPr>
-          <p:cNvPr id="13" name="TextBox 12"/>
+          <p:cNvPr id="15" name="TextBox 14"/>
           <p:cNvSpPr txBox="1"/>
           <p:nvPr/>
         </p:nvSpPr>
@@ -4924,7 +5015,7 @@
       </p:sp>
       <p:sp>
         <p:nvSpPr>
-          <p:cNvPr id="14" name="TextBox 13"/>
+          <p:cNvPr id="16" name="TextBox 15"/>
           <p:cNvSpPr txBox="1"/>
           <p:nvPr/>
         </p:nvSpPr>
@@ -4976,7 +5067,7 @@
       </p:sp>
       <p:sp>
         <p:nvSpPr>
-          <p:cNvPr id="15" name="Rounded Rectangle 14"/>
+          <p:cNvPr id="17" name="Rounded Rectangle 16"/>
           <p:cNvSpPr/>
           <p:nvPr/>
         </p:nvSpPr>
@@ -5024,48 +5115,51 @@
       </p:sp>
       <p:sp>
         <p:nvSpPr>
-          <p:cNvPr id="16" name="TextBox 15"/>
-          <p:cNvSpPr txBox="1"/>
-          <p:nvPr/>
-        </p:nvSpPr>
-        <p:spPr>
-          <a:xfrm>
-            <a:off x="1161288" y="4069080"/>
-            <a:ext cx="822960" cy="749808"/>
-          </a:xfrm>
-          <a:prstGeom prst="rect">
-            <a:avLst/>
-          </a:prstGeom>
-          <a:noFill/>
-        </p:spPr>
-        <p:txBody>
-          <a:bodyPr wrap="square" anchor="ctr" lIns="0" rIns="0" tIns="0" bIns="0">
-            <a:spAutoFit/>
-          </a:bodyPr>
-          <a:lstStyle/>
-          <a:p>
-            <a:pPr algn="l">
-              <a:lnSpc>
-                <a:spcPct val="100000"/>
-              </a:lnSpc>
-            </a:pPr>
-            <a:r>
-              <a:rPr sz="2600" b="0" i="0">
-                <a:solidFill>
-                  <a:srgbClr val="F5F5F3"/>
-                </a:solidFill>
-                <a:latin typeface="Segoe UI"/>
-                <a:ea typeface="Malgun Gothic"/>
-                <a:cs typeface="Segoe UI"/>
-              </a:rPr>
-              <a:t>📦</a:t>
-            </a:r>
-          </a:p>
-        </p:txBody>
-      </p:sp>
-      <p:sp>
-        <p:nvSpPr>
-          <p:cNvPr id="17" name="TextBox 16"/>
+          <p:cNvPr id="18" name="Cube 17"/>
+          <p:cNvSpPr/>
+          <p:nvPr/>
+        </p:nvSpPr>
+        <p:spPr>
+          <a:xfrm>
+            <a:off x="1316736" y="4270248"/>
+            <a:ext cx="365760" cy="347472"/>
+          </a:xfrm>
+          <a:prstGeom prst="cube">
+            <a:avLst/>
+          </a:prstGeom>
+          <a:noFill/>
+          <a:ln w="24130">
+            <a:solidFill>
+              <a:srgbClr val="E7B75F"/>
+            </a:solidFill>
+          </a:ln>
+          <a:effectLst/>
+        </p:spPr>
+        <p:style>
+          <a:lnRef idx="1">
+            <a:schemeClr val="accent1"/>
+          </a:lnRef>
+          <a:fillRef idx="3">
+            <a:schemeClr val="accent1"/>
+          </a:fillRef>
+          <a:effectRef idx="2">
+            <a:schemeClr val="accent1"/>
+          </a:effectRef>
+          <a:fontRef idx="minor">
+            <a:schemeClr val="lt1"/>
+          </a:fontRef>
+        </p:style>
+        <p:txBody>
+          <a:bodyPr rtlCol="0" anchor="ctr"/>
+          <a:lstStyle/>
+          <a:p>
+            <a:pPr algn="ctr"/>
+          </a:p>
+        </p:txBody>
+      </p:sp>
+      <p:sp>
+        <p:nvSpPr>
+          <p:cNvPr id="19" name="TextBox 18"/>
           <p:cNvSpPr txBox="1"/>
           <p:nvPr/>
         </p:nvSpPr>
@@ -5106,7 +5200,7 @@
       </p:sp>
       <p:sp>
         <p:nvSpPr>
-          <p:cNvPr id="18" name="TextBox 17"/>
+          <p:cNvPr id="20" name="TextBox 19"/>
           <p:cNvSpPr txBox="1"/>
           <p:nvPr/>
         </p:nvSpPr>
@@ -5147,7 +5241,7 @@
       </p:sp>
       <p:sp>
         <p:nvSpPr>
-          <p:cNvPr id="19" name="TextBox 18"/>
+          <p:cNvPr id="21" name="TextBox 20"/>
           <p:cNvSpPr txBox="1"/>
           <p:nvPr/>
         </p:nvSpPr>
@@ -5199,7 +5293,7 @@
       </p:sp>
       <p:sp>
         <p:nvSpPr>
-          <p:cNvPr id="20" name="Rounded Rectangle 19"/>
+          <p:cNvPr id="22" name="Rounded Rectangle 21"/>
           <p:cNvSpPr/>
           <p:nvPr/>
         </p:nvSpPr>
@@ -5247,48 +5341,51 @@
       </p:sp>
       <p:sp>
         <p:nvSpPr>
-          <p:cNvPr id="21" name="TextBox 20"/>
-          <p:cNvSpPr txBox="1"/>
-          <p:nvPr/>
-        </p:nvSpPr>
-        <p:spPr>
-          <a:xfrm>
-            <a:off x="1161288" y="4892040"/>
-            <a:ext cx="822960" cy="749808"/>
-          </a:xfrm>
-          <a:prstGeom prst="rect">
-            <a:avLst/>
-          </a:prstGeom>
-          <a:noFill/>
-        </p:spPr>
-        <p:txBody>
-          <a:bodyPr wrap="square" anchor="ctr" lIns="0" rIns="0" tIns="0" bIns="0">
-            <a:spAutoFit/>
-          </a:bodyPr>
-          <a:lstStyle/>
-          <a:p>
-            <a:pPr algn="l">
-              <a:lnSpc>
-                <a:spcPct val="100000"/>
-              </a:lnSpc>
-            </a:pPr>
-            <a:r>
-              <a:rPr sz="2600" b="0" i="0">
-                <a:solidFill>
-                  <a:srgbClr val="F5F5F3"/>
-                </a:solidFill>
-                <a:latin typeface="Segoe UI"/>
-                <a:ea typeface="Malgun Gothic"/>
-                <a:cs typeface="Segoe UI"/>
-              </a:rPr>
-              <a:t>🎏</a:t>
-            </a:r>
-          </a:p>
-        </p:txBody>
-      </p:sp>
-      <p:sp>
-        <p:nvSpPr>
-          <p:cNvPr id="22" name="TextBox 21"/>
+          <p:cNvPr id="23" name="Can 22"/>
+          <p:cNvSpPr/>
+          <p:nvPr/>
+        </p:nvSpPr>
+        <p:spPr>
+          <a:xfrm>
+            <a:off x="1349654" y="5084064"/>
+            <a:ext cx="299923" cy="365760"/>
+          </a:xfrm>
+          <a:prstGeom prst="can">
+            <a:avLst/>
+          </a:prstGeom>
+          <a:noFill/>
+          <a:ln w="24130">
+            <a:solidFill>
+              <a:srgbClr val="E7B75F"/>
+            </a:solidFill>
+          </a:ln>
+          <a:effectLst/>
+        </p:spPr>
+        <p:style>
+          <a:lnRef idx="1">
+            <a:schemeClr val="accent1"/>
+          </a:lnRef>
+          <a:fillRef idx="3">
+            <a:schemeClr val="accent1"/>
+          </a:fillRef>
+          <a:effectRef idx="2">
+            <a:schemeClr val="accent1"/>
+          </a:effectRef>
+          <a:fontRef idx="minor">
+            <a:schemeClr val="lt1"/>
+          </a:fontRef>
+        </p:style>
+        <p:txBody>
+          <a:bodyPr rtlCol="0" anchor="ctr"/>
+          <a:lstStyle/>
+          <a:p>
+            <a:pPr algn="ctr"/>
+          </a:p>
+        </p:txBody>
+      </p:sp>
+      <p:sp>
+        <p:nvSpPr>
+          <p:cNvPr id="24" name="TextBox 23"/>
           <p:cNvSpPr txBox="1"/>
           <p:nvPr/>
         </p:nvSpPr>
@@ -5329,7 +5426,7 @@
       </p:sp>
       <p:sp>
         <p:nvSpPr>
-          <p:cNvPr id="23" name="TextBox 22"/>
+          <p:cNvPr id="25" name="TextBox 24"/>
           <p:cNvSpPr txBox="1"/>
           <p:nvPr/>
         </p:nvSpPr>
@@ -5370,7 +5467,7 @@
       </p:sp>
       <p:sp>
         <p:nvSpPr>
-          <p:cNvPr id="24" name="TextBox 23"/>
+          <p:cNvPr id="26" name="TextBox 25"/>
           <p:cNvSpPr txBox="1"/>
           <p:nvPr/>
         </p:nvSpPr>
@@ -5422,7 +5519,7 @@
       </p:sp>
       <p:sp>
         <p:nvSpPr>
-          <p:cNvPr id="25" name="TextBox 24"/>
+          <p:cNvPr id="27" name="TextBox 26"/>
           <p:cNvSpPr txBox="1"/>
           <p:nvPr/>
         </p:nvSpPr>
@@ -8142,48 +8239,95 @@
       </p:sp>
       <p:sp>
         <p:nvSpPr>
-          <p:cNvPr id="11" name="TextBox 10"/>
-          <p:cNvSpPr txBox="1"/>
-          <p:nvPr/>
-        </p:nvSpPr>
-        <p:spPr>
-          <a:xfrm>
-            <a:off x="1161288" y="2724912"/>
-            <a:ext cx="914400" cy="457200"/>
-          </a:xfrm>
-          <a:prstGeom prst="rect">
-            <a:avLst/>
-          </a:prstGeom>
-          <a:noFill/>
-        </p:spPr>
-        <p:txBody>
-          <a:bodyPr wrap="square" anchor="t" lIns="0" rIns="0" tIns="0" bIns="0">
-            <a:spAutoFit/>
-          </a:bodyPr>
-          <a:lstStyle/>
-          <a:p>
-            <a:pPr algn="l">
-              <a:lnSpc>
-                <a:spcPct val="100000"/>
-              </a:lnSpc>
-            </a:pPr>
-            <a:r>
-              <a:rPr sz="2400" b="0" i="0">
-                <a:solidFill>
-                  <a:srgbClr val="F5F5F3"/>
-                </a:solidFill>
-                <a:latin typeface="Segoe UI"/>
-                <a:ea typeface="Malgun Gothic"/>
-                <a:cs typeface="Segoe UI"/>
-              </a:rPr>
-              <a:t>💵</a:t>
-            </a:r>
-          </a:p>
-        </p:txBody>
-      </p:sp>
-      <p:sp>
-        <p:nvSpPr>
-          <p:cNvPr id="12" name="TextBox 11"/>
+          <p:cNvPr id="11" name="Rounded Rectangle 10"/>
+          <p:cNvSpPr/>
+          <p:nvPr/>
+        </p:nvSpPr>
+        <p:spPr>
+          <a:xfrm>
+            <a:off x="1207008" y="2915107"/>
+            <a:ext cx="402336" cy="241401"/>
+          </a:xfrm>
+          <a:prstGeom prst="roundRect">
+            <a:avLst/>
+          </a:prstGeom>
+          <a:noFill/>
+          <a:ln w="24130">
+            <a:solidFill>
+              <a:srgbClr val="F2CE8A"/>
+            </a:solidFill>
+          </a:ln>
+          <a:effectLst/>
+        </p:spPr>
+        <p:style>
+          <a:lnRef idx="1">
+            <a:schemeClr val="accent1"/>
+          </a:lnRef>
+          <a:fillRef idx="3">
+            <a:schemeClr val="accent1"/>
+          </a:fillRef>
+          <a:effectRef idx="2">
+            <a:schemeClr val="accent1"/>
+          </a:effectRef>
+          <a:fontRef idx="minor">
+            <a:schemeClr val="lt1"/>
+          </a:fontRef>
+        </p:style>
+        <p:txBody>
+          <a:bodyPr rtlCol="0" anchor="ctr"/>
+          <a:lstStyle/>
+          <a:p>
+            <a:pPr algn="ctr"/>
+          </a:p>
+        </p:txBody>
+      </p:sp>
+      <p:sp>
+        <p:nvSpPr>
+          <p:cNvPr id="12" name="Oval 11"/>
+          <p:cNvSpPr/>
+          <p:nvPr/>
+        </p:nvSpPr>
+        <p:spPr>
+          <a:xfrm>
+            <a:off x="1347825" y="2975457"/>
+            <a:ext cx="120700" cy="120700"/>
+          </a:xfrm>
+          <a:prstGeom prst="ellipse">
+            <a:avLst/>
+          </a:prstGeom>
+          <a:noFill/>
+          <a:ln w="24130">
+            <a:solidFill>
+              <a:srgbClr val="F2CE8A"/>
+            </a:solidFill>
+          </a:ln>
+          <a:effectLst/>
+        </p:spPr>
+        <p:style>
+          <a:lnRef idx="1">
+            <a:schemeClr val="accent1"/>
+          </a:lnRef>
+          <a:fillRef idx="3">
+            <a:schemeClr val="accent1"/>
+          </a:fillRef>
+          <a:effectRef idx="2">
+            <a:schemeClr val="accent1"/>
+          </a:effectRef>
+          <a:fontRef idx="minor">
+            <a:schemeClr val="lt1"/>
+          </a:fontRef>
+        </p:style>
+        <p:txBody>
+          <a:bodyPr rtlCol="0" anchor="ctr"/>
+          <a:lstStyle/>
+          <a:p>
+            <a:pPr algn="ctr"/>
+          </a:p>
+        </p:txBody>
+      </p:sp>
+      <p:sp>
+        <p:nvSpPr>
+          <p:cNvPr id="13" name="TextBox 12"/>
           <p:cNvSpPr txBox="1"/>
           <p:nvPr/>
         </p:nvSpPr>
@@ -8224,7 +8368,7 @@
       </p:sp>
       <p:sp>
         <p:nvSpPr>
-          <p:cNvPr id="13" name="TextBox 12"/>
+          <p:cNvPr id="14" name="TextBox 13"/>
           <p:cNvSpPr txBox="1"/>
           <p:nvPr/>
         </p:nvSpPr>
@@ -8265,7 +8409,7 @@
       </p:sp>
       <p:sp>
         <p:nvSpPr>
-          <p:cNvPr id="14" name="Rounded Rectangle 13"/>
+          <p:cNvPr id="15" name="Rounded Rectangle 14"/>
           <p:cNvSpPr/>
           <p:nvPr/>
         </p:nvSpPr>
@@ -8313,48 +8457,167 @@
       </p:sp>
       <p:sp>
         <p:nvSpPr>
-          <p:cNvPr id="15" name="TextBox 14"/>
-          <p:cNvSpPr txBox="1"/>
-          <p:nvPr/>
-        </p:nvSpPr>
-        <p:spPr>
-          <a:xfrm>
-            <a:off x="6598767" y="2724912"/>
-            <a:ext cx="914400" cy="457200"/>
-          </a:xfrm>
-          <a:prstGeom prst="rect">
-            <a:avLst/>
-          </a:prstGeom>
-          <a:noFill/>
-        </p:spPr>
-        <p:txBody>
-          <a:bodyPr wrap="square" anchor="t" lIns="0" rIns="0" tIns="0" bIns="0">
-            <a:spAutoFit/>
-          </a:bodyPr>
-          <a:lstStyle/>
-          <a:p>
-            <a:pPr algn="l">
-              <a:lnSpc>
-                <a:spcPct val="100000"/>
-              </a:lnSpc>
-            </a:pPr>
-            <a:r>
-              <a:rPr sz="2400" b="0" i="0">
-                <a:solidFill>
-                  <a:srgbClr val="F5F5F3"/>
-                </a:solidFill>
-                <a:latin typeface="Segoe UI"/>
-                <a:ea typeface="Malgun Gothic"/>
-                <a:cs typeface="Segoe UI"/>
-              </a:rPr>
-              <a:t>🪪</a:t>
-            </a:r>
-          </a:p>
-        </p:txBody>
-      </p:sp>
-      <p:sp>
-        <p:nvSpPr>
-          <p:cNvPr id="16" name="TextBox 15"/>
+          <p:cNvPr id="16" name="Rounded Rectangle 15"/>
+          <p:cNvSpPr/>
+          <p:nvPr/>
+        </p:nvSpPr>
+        <p:spPr>
+          <a:xfrm>
+            <a:off x="6644487" y="2903037"/>
+            <a:ext cx="402336" cy="265541"/>
+          </a:xfrm>
+          <a:prstGeom prst="roundRect">
+            <a:avLst/>
+          </a:prstGeom>
+          <a:noFill/>
+          <a:ln w="24130">
+            <a:solidFill>
+              <a:srgbClr val="F2CE8A"/>
+            </a:solidFill>
+          </a:ln>
+          <a:effectLst/>
+        </p:spPr>
+        <p:style>
+          <a:lnRef idx="1">
+            <a:schemeClr val="accent1"/>
+          </a:lnRef>
+          <a:fillRef idx="3">
+            <a:schemeClr val="accent1"/>
+          </a:fillRef>
+          <a:effectRef idx="2">
+            <a:schemeClr val="accent1"/>
+          </a:effectRef>
+          <a:fontRef idx="minor">
+            <a:schemeClr val="lt1"/>
+          </a:fontRef>
+        </p:style>
+        <p:txBody>
+          <a:bodyPr rtlCol="0" anchor="ctr"/>
+          <a:lstStyle/>
+          <a:p>
+            <a:pPr algn="ctr"/>
+          </a:p>
+        </p:txBody>
+      </p:sp>
+      <p:sp>
+        <p:nvSpPr>
+          <p:cNvPr id="17" name="Oval 16"/>
+          <p:cNvSpPr/>
+          <p:nvPr/>
+        </p:nvSpPr>
+        <p:spPr>
+          <a:xfrm>
+            <a:off x="6696791" y="2967410"/>
+            <a:ext cx="120700" cy="120700"/>
+          </a:xfrm>
+          <a:prstGeom prst="ellipse">
+            <a:avLst/>
+          </a:prstGeom>
+          <a:noFill/>
+          <a:ln w="24130">
+            <a:solidFill>
+              <a:srgbClr val="F2CE8A"/>
+            </a:solidFill>
+          </a:ln>
+          <a:effectLst/>
+        </p:spPr>
+        <p:style>
+          <a:lnRef idx="1">
+            <a:schemeClr val="accent1"/>
+          </a:lnRef>
+          <a:fillRef idx="3">
+            <a:schemeClr val="accent1"/>
+          </a:fillRef>
+          <a:effectRef idx="2">
+            <a:schemeClr val="accent1"/>
+          </a:effectRef>
+          <a:fontRef idx="minor">
+            <a:schemeClr val="lt1"/>
+          </a:fontRef>
+        </p:style>
+        <p:txBody>
+          <a:bodyPr rtlCol="0" anchor="ctr"/>
+          <a:lstStyle/>
+          <a:p>
+            <a:pPr algn="ctr"/>
+          </a:p>
+        </p:txBody>
+      </p:sp>
+      <p:cxnSp>
+        <p:nvCxnSpPr>
+          <p:cNvPr id="18" name="Connector 17"/>
+          <p:cNvCxnSpPr/>
+          <p:nvPr/>
+        </p:nvCxnSpPr>
+        <p:spPr>
+          <a:xfrm>
+            <a:off x="6853702" y="2995574"/>
+            <a:ext cx="140817" cy="0"/>
+          </a:xfrm>
+          <a:prstGeom prst="line">
+            <a:avLst/>
+          </a:prstGeom>
+          <a:ln w="17780">
+            <a:solidFill>
+              <a:srgbClr val="F2CE8A"/>
+            </a:solidFill>
+          </a:ln>
+          <a:effectLst/>
+        </p:spPr>
+        <p:style>
+          <a:lnRef idx="2">
+            <a:schemeClr val="accent1"/>
+          </a:lnRef>
+          <a:fillRef idx="0">
+            <a:schemeClr val="accent1"/>
+          </a:fillRef>
+          <a:effectRef idx="1">
+            <a:schemeClr val="accent1"/>
+          </a:effectRef>
+          <a:fontRef idx="minor">
+            <a:schemeClr val="tx1"/>
+          </a:fontRef>
+        </p:style>
+      </p:cxnSp>
+      <p:cxnSp>
+        <p:nvCxnSpPr>
+          <p:cNvPr id="19" name="Connector 18"/>
+          <p:cNvCxnSpPr/>
+          <p:nvPr/>
+        </p:nvCxnSpPr>
+        <p:spPr>
+          <a:xfrm>
+            <a:off x="6853702" y="3063971"/>
+            <a:ext cx="140817" cy="0"/>
+          </a:xfrm>
+          <a:prstGeom prst="line">
+            <a:avLst/>
+          </a:prstGeom>
+          <a:ln w="17780">
+            <a:solidFill>
+              <a:srgbClr val="F2CE8A"/>
+            </a:solidFill>
+          </a:ln>
+          <a:effectLst/>
+        </p:spPr>
+        <p:style>
+          <a:lnRef idx="2">
+            <a:schemeClr val="accent1"/>
+          </a:lnRef>
+          <a:fillRef idx="0">
+            <a:schemeClr val="accent1"/>
+          </a:fillRef>
+          <a:effectRef idx="1">
+            <a:schemeClr val="accent1"/>
+          </a:effectRef>
+          <a:fontRef idx="minor">
+            <a:schemeClr val="tx1"/>
+          </a:fontRef>
+        </p:style>
+      </p:cxnSp>
+      <p:sp>
+        <p:nvSpPr>
+          <p:cNvPr id="20" name="TextBox 19"/>
           <p:cNvSpPr txBox="1"/>
           <p:nvPr/>
         </p:nvSpPr>
@@ -8395,7 +8658,7 @@
       </p:sp>
       <p:sp>
         <p:nvSpPr>
-          <p:cNvPr id="17" name="TextBox 16"/>
+          <p:cNvPr id="21" name="TextBox 20"/>
           <p:cNvSpPr txBox="1"/>
           <p:nvPr/>
         </p:nvSpPr>
@@ -8436,7 +8699,7 @@
       </p:sp>
       <p:sp>
         <p:nvSpPr>
-          <p:cNvPr id="18" name="Rounded Rectangle 17"/>
+          <p:cNvPr id="22" name="Rounded Rectangle 21"/>
           <p:cNvSpPr/>
           <p:nvPr/>
         </p:nvSpPr>
@@ -8484,48 +8747,87 @@
       </p:sp>
       <p:sp>
         <p:nvSpPr>
-          <p:cNvPr id="19" name="TextBox 18"/>
-          <p:cNvSpPr txBox="1"/>
-          <p:nvPr/>
-        </p:nvSpPr>
-        <p:spPr>
-          <a:xfrm>
-            <a:off x="1161288" y="4416552"/>
-            <a:ext cx="914400" cy="457200"/>
-          </a:xfrm>
-          <a:prstGeom prst="rect">
-            <a:avLst/>
-          </a:prstGeom>
-          <a:noFill/>
-        </p:spPr>
-        <p:txBody>
-          <a:bodyPr wrap="square" anchor="t" lIns="0" rIns="0" tIns="0" bIns="0">
-            <a:spAutoFit/>
-          </a:bodyPr>
-          <a:lstStyle/>
-          <a:p>
-            <a:pPr algn="l">
-              <a:lnSpc>
-                <a:spcPct val="100000"/>
-              </a:lnSpc>
-            </a:pPr>
-            <a:r>
-              <a:rPr sz="2400" b="0" i="0">
-                <a:solidFill>
-                  <a:srgbClr val="F5F5F3"/>
-                </a:solidFill>
-                <a:latin typeface="Segoe UI"/>
-                <a:ea typeface="Malgun Gothic"/>
-                <a:cs typeface="Segoe UI"/>
-              </a:rPr>
-              <a:t>📱</a:t>
-            </a:r>
-          </a:p>
-        </p:txBody>
-      </p:sp>
-      <p:sp>
-        <p:nvSpPr>
-          <p:cNvPr id="20" name="TextBox 19"/>
+          <p:cNvPr id="23" name="Rounded Rectangle 22"/>
+          <p:cNvSpPr/>
+          <p:nvPr/>
+        </p:nvSpPr>
+        <p:spPr>
+          <a:xfrm>
+            <a:off x="1287475" y="4526280"/>
+            <a:ext cx="241401" cy="402336"/>
+          </a:xfrm>
+          <a:prstGeom prst="roundRect">
+            <a:avLst/>
+          </a:prstGeom>
+          <a:noFill/>
+          <a:ln w="24130">
+            <a:solidFill>
+              <a:srgbClr val="F2CE8A"/>
+            </a:solidFill>
+          </a:ln>
+          <a:effectLst/>
+        </p:spPr>
+        <p:style>
+          <a:lnRef idx="1">
+            <a:schemeClr val="accent1"/>
+          </a:lnRef>
+          <a:fillRef idx="3">
+            <a:schemeClr val="accent1"/>
+          </a:fillRef>
+          <a:effectRef idx="2">
+            <a:schemeClr val="accent1"/>
+          </a:effectRef>
+          <a:fontRef idx="minor">
+            <a:schemeClr val="lt1"/>
+          </a:fontRef>
+        </p:style>
+        <p:txBody>
+          <a:bodyPr rtlCol="0" anchor="ctr"/>
+          <a:lstStyle/>
+          <a:p>
+            <a:pPr algn="ctr"/>
+          </a:p>
+        </p:txBody>
+      </p:sp>
+      <p:cxnSp>
+        <p:nvCxnSpPr>
+          <p:cNvPr id="24" name="Connector 23"/>
+          <p:cNvCxnSpPr/>
+          <p:nvPr/>
+        </p:nvCxnSpPr>
+        <p:spPr>
+          <a:xfrm>
+            <a:off x="1375989" y="4860218"/>
+            <a:ext cx="64373" cy="0"/>
+          </a:xfrm>
+          <a:prstGeom prst="line">
+            <a:avLst/>
+          </a:prstGeom>
+          <a:ln w="20320">
+            <a:solidFill>
+              <a:srgbClr val="F2CE8A"/>
+            </a:solidFill>
+          </a:ln>
+          <a:effectLst/>
+        </p:spPr>
+        <p:style>
+          <a:lnRef idx="2">
+            <a:schemeClr val="accent1"/>
+          </a:lnRef>
+          <a:fillRef idx="0">
+            <a:schemeClr val="accent1"/>
+          </a:fillRef>
+          <a:effectRef idx="1">
+            <a:schemeClr val="accent1"/>
+          </a:effectRef>
+          <a:fontRef idx="minor">
+            <a:schemeClr val="tx1"/>
+          </a:fontRef>
+        </p:style>
+      </p:cxnSp>
+      <p:sp>
+        <p:nvSpPr>
+          <p:cNvPr id="25" name="TextBox 24"/>
           <p:cNvSpPr txBox="1"/>
           <p:nvPr/>
         </p:nvSpPr>
@@ -8566,7 +8868,7 @@
       </p:sp>
       <p:sp>
         <p:nvSpPr>
-          <p:cNvPr id="21" name="TextBox 20"/>
+          <p:cNvPr id="26" name="TextBox 25"/>
           <p:cNvSpPr txBox="1"/>
           <p:nvPr/>
         </p:nvSpPr>
@@ -8607,7 +8909,7 @@
       </p:sp>
       <p:sp>
         <p:nvSpPr>
-          <p:cNvPr id="22" name="Rounded Rectangle 21"/>
+          <p:cNvPr id="27" name="Rounded Rectangle 26"/>
           <p:cNvSpPr/>
           <p:nvPr/>
         </p:nvSpPr>
@@ -8655,48 +8957,51 @@
       </p:sp>
       <p:sp>
         <p:nvSpPr>
-          <p:cNvPr id="23" name="TextBox 22"/>
-          <p:cNvSpPr txBox="1"/>
-          <p:nvPr/>
-        </p:nvSpPr>
-        <p:spPr>
-          <a:xfrm>
-            <a:off x="6598767" y="4416552"/>
-            <a:ext cx="914400" cy="457200"/>
-          </a:xfrm>
-          <a:prstGeom prst="rect">
-            <a:avLst/>
-          </a:prstGeom>
-          <a:noFill/>
-        </p:spPr>
-        <p:txBody>
-          <a:bodyPr wrap="square" anchor="t" lIns="0" rIns="0" tIns="0" bIns="0">
-            <a:spAutoFit/>
-          </a:bodyPr>
-          <a:lstStyle/>
-          <a:p>
-            <a:pPr algn="l">
-              <a:lnSpc>
-                <a:spcPct val="100000"/>
-              </a:lnSpc>
-            </a:pPr>
-            <a:r>
-              <a:rPr sz="2400" b="0" i="0">
-                <a:solidFill>
-                  <a:srgbClr val="F5F5F3"/>
-                </a:solidFill>
-                <a:latin typeface="Segoe UI"/>
-                <a:ea typeface="Malgun Gothic"/>
-                <a:cs typeface="Segoe UI"/>
-              </a:rPr>
-              <a:t>⚡</a:t>
-            </a:r>
-          </a:p>
-        </p:txBody>
-      </p:sp>
-      <p:sp>
-        <p:nvSpPr>
-          <p:cNvPr id="24" name="TextBox 23"/>
+          <p:cNvPr id="28" name="Lightning Bolt 27"/>
+          <p:cNvSpPr/>
+          <p:nvPr/>
+        </p:nvSpPr>
+        <p:spPr>
+          <a:xfrm>
+            <a:off x="6720931" y="4526280"/>
+            <a:ext cx="249448" cy="402336"/>
+          </a:xfrm>
+          <a:prstGeom prst="lightningBolt">
+            <a:avLst/>
+          </a:prstGeom>
+          <a:solidFill>
+            <a:srgbClr val="F2CE8A"/>
+          </a:solidFill>
+          <a:ln>
+            <a:noFill/>
+          </a:ln>
+          <a:effectLst/>
+        </p:spPr>
+        <p:style>
+          <a:lnRef idx="1">
+            <a:schemeClr val="accent1"/>
+          </a:lnRef>
+          <a:fillRef idx="3">
+            <a:schemeClr val="accent1"/>
+          </a:fillRef>
+          <a:effectRef idx="2">
+            <a:schemeClr val="accent1"/>
+          </a:effectRef>
+          <a:fontRef idx="minor">
+            <a:schemeClr val="lt1"/>
+          </a:fontRef>
+        </p:style>
+        <p:txBody>
+          <a:bodyPr rtlCol="0" anchor="ctr"/>
+          <a:lstStyle/>
+          <a:p>
+            <a:pPr algn="ctr"/>
+          </a:p>
+        </p:txBody>
+      </p:sp>
+      <p:sp>
+        <p:nvSpPr>
+          <p:cNvPr id="29" name="TextBox 28"/>
           <p:cNvSpPr txBox="1"/>
           <p:nvPr/>
         </p:nvSpPr>
@@ -8737,7 +9042,7 @@
       </p:sp>
       <p:sp>
         <p:nvSpPr>
-          <p:cNvPr id="25" name="TextBox 24"/>
+          <p:cNvPr id="30" name="TextBox 29"/>
           <p:cNvSpPr txBox="1"/>
           <p:nvPr/>
         </p:nvSpPr>

</xml_diff>